<commit_message>
BPM submission: 4 main figs + 2 SDC, bracketed refs, vector/TIFF export, tone pass
- Consolidate to 4 main figures + 2 tables (six display items); move signal
  decomposition and CCC range-dependence to Supplemental Digital Content.
- Add separately-numbered submission figures (Figure1-4, SDC1-2) as TIFF and
  vector PDF; select Arial/Helvetica when available.
- Single-source dynamic-system parameters via summary.json (no hard-coded
  labels); add dyn_systems to results parameters.
- Cover letter: article type, item counts, AI/synthetic-data disclosures.
- Tone pass on the English manuscript (reduce em-dash/AI-style phrasing).
- Update README/Makefile for new outputs and clean rules.

Co-Authored-By: Tatsuki Onishi <bougtoir@gmail.com>
</commit_message>
<xml_diff>
--- a/zero_calibration_bpm/manuscripts/BPM_Figures_EN.pptx
+++ b/zero_calibration_bpm/manuscripts/BPM_Figures_EN.pptx
@@ -3118,7 +3118,411 @@
             <a:pPr algn="l"/>
             <a:r>
               <a:rPr sz="2400" b="1"/>
-              <a:t>Figure 1. Signal decomposition</a:t>
+              <a:t>Figure 1. Concordance by scenario</a:t>
+            </a:r>
+          </a:p>
+        </p:txBody>
+      </p:sp>
+      <p:pic>
+        <p:nvPicPr>
+          <p:cNvPr id="3" name="Picture 2" descr="figure2_scenarios_concordance.png"/>
+          <p:cNvPicPr>
+            <a:picLocks noChangeAspect="1"/>
+          </p:cNvPicPr>
+          <p:nvPr/>
+        </p:nvPicPr>
+        <p:blipFill>
+          <a:blip r:embed="rId2"/>
+          <a:stretch>
+            <a:fillRect/>
+          </a:stretch>
+        </p:blipFill>
+        <p:spPr>
+          <a:xfrm>
+            <a:off x="3555847" y="960120"/>
+            <a:ext cx="5080000" cy="4572000"/>
+          </a:xfrm>
+          <a:prstGeom prst="rect">
+            <a:avLst/>
+          </a:prstGeom>
+        </p:spPr>
+      </p:pic>
+      <p:sp>
+        <p:nvSpPr>
+          <p:cNvPr id="4" name="TextBox 3"/>
+          <p:cNvSpPr txBox="1"/>
+          <p:nvPr/>
+        </p:nvSpPr>
+        <p:spPr>
+          <a:xfrm>
+            <a:off x="457200" y="5760720"/>
+            <a:ext cx="11277295" cy="914400"/>
+          </a:xfrm>
+          <a:prstGeom prst="rect">
+            <a:avLst/>
+          </a:prstGeom>
+          <a:noFill/>
+        </p:spPr>
+        <p:txBody>
+          <a:bodyPr wrap="square">
+            <a:spAutoFit/>
+          </a:bodyPr>
+          <a:lstStyle/>
+          <a:p>
+            <a:r>
+              <a:rPr sz="1300" i="1"/>
+              <a:t>Device-versus-reference concordance for the four static scenarios; each panel shows CCC, scale shift v and mean bias. S4 has near-zero bias despite a 10% gain error.</a:t>
+            </a:r>
+          </a:p>
+        </p:txBody>
+      </p:sp>
+    </p:spTree>
+  </p:cSld>
+  <p:clrMapOvr>
+    <a:masterClrMapping/>
+  </p:clrMapOvr>
+</p:sld>
+</file>
+
+<file path=ppt/slides/slide2.xml><?xml version="1.0" encoding="utf-8"?>
+<p:sld xmlns:a="http://schemas.openxmlformats.org/drawingml/2006/main" xmlns:p="http://schemas.openxmlformats.org/presentationml/2006/main" xmlns:r="http://schemas.openxmlformats.org/officeDocument/2006/relationships">
+  <p:cSld>
+    <p:spTree>
+      <p:nvGrpSpPr>
+        <p:cNvPr id="1" name=""/>
+        <p:cNvGrpSpPr/>
+        <p:nvPr/>
+      </p:nvGrpSpPr>
+      <p:grpSpPr/>
+      <p:sp>
+        <p:nvSpPr>
+          <p:cNvPr id="2" name="TextBox 1"/>
+          <p:cNvSpPr txBox="1"/>
+          <p:nvPr/>
+        </p:nvSpPr>
+        <p:spPr>
+          <a:xfrm>
+            <a:off x="457200" y="182880"/>
+            <a:ext cx="11277295" cy="640080"/>
+          </a:xfrm>
+          <a:prstGeom prst="rect">
+            <a:avLst/>
+          </a:prstGeom>
+          <a:noFill/>
+        </p:spPr>
+        <p:txBody>
+          <a:bodyPr wrap="square">
+            <a:spAutoFit/>
+          </a:bodyPr>
+          <a:lstStyle/>
+          <a:p>
+            <a:pPr algn="l"/>
+            <a:r>
+              <a:rPr sz="2400" b="1"/>
+              <a:t>Figure 2. Detection pattern</a:t>
+            </a:r>
+          </a:p>
+        </p:txBody>
+      </p:sp>
+      <p:pic>
+        <p:nvPicPr>
+          <p:cNvPr id="3" name="Picture 2" descr="figure3_detection_panel.png"/>
+          <p:cNvPicPr>
+            <a:picLocks noChangeAspect="1"/>
+          </p:cNvPicPr>
+          <p:nvPr/>
+        </p:nvPicPr>
+        <p:blipFill>
+          <a:blip r:embed="rId2"/>
+          <a:stretch>
+            <a:fillRect/>
+          </a:stretch>
+        </p:blipFill>
+        <p:spPr>
+          <a:xfrm>
+            <a:off x="2209647" y="960120"/>
+            <a:ext cx="7772400" cy="4572000"/>
+          </a:xfrm>
+          <a:prstGeom prst="rect">
+            <a:avLst/>
+          </a:prstGeom>
+        </p:spPr>
+      </p:pic>
+      <p:sp>
+        <p:nvSpPr>
+          <p:cNvPr id="4" name="TextBox 3"/>
+          <p:cNvSpPr txBox="1"/>
+          <p:nvPr/>
+        </p:nvSpPr>
+        <p:spPr>
+          <a:xfrm>
+            <a:off x="457200" y="5760720"/>
+            <a:ext cx="11277295" cy="914400"/>
+          </a:xfrm>
+          <a:prstGeom prst="rect">
+            <a:avLst/>
+          </a:prstGeom>
+          <a:noFill/>
+        </p:spPr>
+        <p:txBody>
+          <a:bodyPr wrap="square">
+            <a:spAutoFit/>
+          </a:bodyPr>
+          <a:lstStyle/>
+          <a:p>
+            <a:r>
+              <a:rPr sz="1300" i="1"/>
+              <a:t>Which reported analysis detects the error in each scenario (green = detected, grey = missed). In S4 the mean-bias summary misses the gain error that all proportional-bias–aware analyses detect.</a:t>
+            </a:r>
+          </a:p>
+        </p:txBody>
+      </p:sp>
+    </p:spTree>
+  </p:cSld>
+  <p:clrMapOvr>
+    <a:masterClrMapping/>
+  </p:clrMapOvr>
+</p:sld>
+</file>
+
+<file path=ppt/slides/slide3.xml><?xml version="1.0" encoding="utf-8"?>
+<p:sld xmlns:a="http://schemas.openxmlformats.org/drawingml/2006/main" xmlns:p="http://schemas.openxmlformats.org/presentationml/2006/main" xmlns:r="http://schemas.openxmlformats.org/officeDocument/2006/relationships">
+  <p:cSld>
+    <p:spTree>
+      <p:nvGrpSpPr>
+        <p:cNvPr id="1" name=""/>
+        <p:cNvGrpSpPr/>
+        <p:nvPr/>
+      </p:nvGrpSpPr>
+      <p:grpSpPr/>
+      <p:sp>
+        <p:nvSpPr>
+          <p:cNvPr id="2" name="TextBox 1"/>
+          <p:cNvSpPr txBox="1"/>
+          <p:nvPr/>
+        </p:nvSpPr>
+        <p:spPr>
+          <a:xfrm>
+            <a:off x="457200" y="182880"/>
+            <a:ext cx="11277295" cy="640080"/>
+          </a:xfrm>
+          <a:prstGeom prst="rect">
+            <a:avLst/>
+          </a:prstGeom>
+          <a:noFill/>
+        </p:spPr>
+        <p:txBody>
+          <a:bodyPr wrap="square">
+            <a:spAutoFit/>
+          </a:bodyPr>
+          <a:lstStyle/>
+          <a:p>
+            <a:pPr algn="l"/>
+            <a:r>
+              <a:rPr sz="2400" b="1"/>
+              <a:t>Figure 3. Bland–Altman regression</a:t>
+            </a:r>
+          </a:p>
+        </p:txBody>
+      </p:sp>
+      <p:pic>
+        <p:nvPicPr>
+          <p:cNvPr id="3" name="Picture 2" descr="figure4_ba_masked_gain.png"/>
+          <p:cNvPicPr>
+            <a:picLocks noChangeAspect="1"/>
+          </p:cNvPicPr>
+          <p:nvPr/>
+        </p:nvPicPr>
+        <p:blipFill>
+          <a:blip r:embed="rId2"/>
+          <a:stretch>
+            <a:fillRect/>
+          </a:stretch>
+        </p:blipFill>
+        <p:spPr>
+          <a:xfrm>
+            <a:off x="629325" y="960120"/>
+            <a:ext cx="10933043" cy="4572000"/>
+          </a:xfrm>
+          <a:prstGeom prst="rect">
+            <a:avLst/>
+          </a:prstGeom>
+        </p:spPr>
+      </p:pic>
+      <p:sp>
+        <p:nvSpPr>
+          <p:cNvPr id="4" name="TextBox 3"/>
+          <p:cNvSpPr txBox="1"/>
+          <p:nvPr/>
+        </p:nvSpPr>
+        <p:spPr>
+          <a:xfrm>
+            <a:off x="457200" y="5760720"/>
+            <a:ext cx="11277295" cy="914400"/>
+          </a:xfrm>
+          <a:prstGeom prst="rect">
+            <a:avLst/>
+          </a:prstGeom>
+          <a:noFill/>
+        </p:spPr>
+        <p:txBody>
+          <a:bodyPr wrap="square">
+            <a:spAutoFit/>
+          </a:bodyPr>
+          <a:lstStyle/>
+          <a:p>
+            <a:r>
+              <a:rPr sz="1300" i="1"/>
+              <a:t>Difference-versus-mean plots for S2 (flat slope) and S4 (positive slope despite near-zero mean bias), revealing the masked proportional (gain) error.</a:t>
+            </a:r>
+          </a:p>
+        </p:txBody>
+      </p:sp>
+    </p:spTree>
+  </p:cSld>
+  <p:clrMapOvr>
+    <a:masterClrMapping/>
+  </p:clrMapOvr>
+</p:sld>
+</file>
+
+<file path=ppt/slides/slide4.xml><?xml version="1.0" encoding="utf-8"?>
+<p:sld xmlns:a="http://schemas.openxmlformats.org/drawingml/2006/main" xmlns:p="http://schemas.openxmlformats.org/presentationml/2006/main" xmlns:r="http://schemas.openxmlformats.org/officeDocument/2006/relationships">
+  <p:cSld>
+    <p:spTree>
+      <p:nvGrpSpPr>
+        <p:cNvPr id="1" name=""/>
+        <p:cNvGrpSpPr/>
+        <p:nvPr/>
+      </p:nvGrpSpPr>
+      <p:grpSpPr/>
+      <p:sp>
+        <p:nvSpPr>
+          <p:cNvPr id="2" name="TextBox 1"/>
+          <p:cNvSpPr txBox="1"/>
+          <p:nvPr/>
+        </p:nvSpPr>
+        <p:spPr>
+          <a:xfrm>
+            <a:off x="457200" y="182880"/>
+            <a:ext cx="11277295" cy="640080"/>
+          </a:xfrm>
+          <a:prstGeom prst="rect">
+            <a:avLst/>
+          </a:prstGeom>
+          <a:noFill/>
+        </p:spPr>
+        <p:txBody>
+          <a:bodyPr wrap="square">
+            <a:spAutoFit/>
+          </a:bodyPr>
+          <a:lstStyle/>
+          <a:p>
+            <a:pPr algn="l"/>
+            <a:r>
+              <a:rPr sz="2400" b="1"/>
+              <a:t>Figure 4. Dynamic response</a:t>
+            </a:r>
+          </a:p>
+        </p:txBody>
+      </p:sp>
+      <p:pic>
+        <p:nvPicPr>
+          <p:cNvPr id="3" name="Picture 2" descr="figure5_dynamic_response.png"/>
+          <p:cNvPicPr>
+            <a:picLocks noChangeAspect="1"/>
+          </p:cNvPicPr>
+          <p:nvPr/>
+        </p:nvPicPr>
+        <p:blipFill>
+          <a:blip r:embed="rId2"/>
+          <a:stretch>
+            <a:fillRect/>
+          </a:stretch>
+        </p:blipFill>
+        <p:spPr>
+          <a:xfrm>
+            <a:off x="457200" y="960120"/>
+            <a:ext cx="11277295" cy="3990427"/>
+          </a:xfrm>
+          <a:prstGeom prst="rect">
+            <a:avLst/>
+          </a:prstGeom>
+        </p:spPr>
+      </p:pic>
+      <p:sp>
+        <p:nvSpPr>
+          <p:cNvPr id="4" name="TextBox 3"/>
+          <p:cNvSpPr txBox="1"/>
+          <p:nvPr/>
+        </p:nvSpPr>
+        <p:spPr>
+          <a:xfrm>
+            <a:off x="457200" y="5760720"/>
+            <a:ext cx="11277295" cy="914400"/>
+          </a:xfrm>
+          <a:prstGeom prst="rect">
+            <a:avLst/>
+          </a:prstGeom>
+          <a:noFill/>
+        </p:spPr>
+        <p:txBody>
+          <a:bodyPr wrap="square">
+            <a:spAutoFit/>
+          </a:bodyPr>
+          <a:lstStyle/>
+          <a:p>
+            <a:r>
+              <a:rPr sz="1300" i="1"/>
+              <a:t>Frequency response and waveforms for optimal, under-damped and over-damped systems, with measured-versus-true pulse pressure and the mean PP ratio.</a:t>
+            </a:r>
+          </a:p>
+        </p:txBody>
+      </p:sp>
+    </p:spTree>
+  </p:cSld>
+  <p:clrMapOvr>
+    <a:masterClrMapping/>
+  </p:clrMapOvr>
+</p:sld>
+</file>
+
+<file path=ppt/slides/slide5.xml><?xml version="1.0" encoding="utf-8"?>
+<p:sld xmlns:a="http://schemas.openxmlformats.org/drawingml/2006/main" xmlns:p="http://schemas.openxmlformats.org/presentationml/2006/main" xmlns:r="http://schemas.openxmlformats.org/officeDocument/2006/relationships">
+  <p:cSld>
+    <p:spTree>
+      <p:nvGrpSpPr>
+        <p:cNvPr id="1" name=""/>
+        <p:cNvGrpSpPr/>
+        <p:nvPr/>
+      </p:nvGrpSpPr>
+      <p:grpSpPr/>
+      <p:sp>
+        <p:nvSpPr>
+          <p:cNvPr id="2" name="TextBox 1"/>
+          <p:cNvSpPr txBox="1"/>
+          <p:nvPr/>
+        </p:nvSpPr>
+        <p:spPr>
+          <a:xfrm>
+            <a:off x="457200" y="182880"/>
+            <a:ext cx="11277295" cy="640080"/>
+          </a:xfrm>
+          <a:prstGeom prst="rect">
+            <a:avLst/>
+          </a:prstGeom>
+          <a:noFill/>
+        </p:spPr>
+        <p:txBody>
+          <a:bodyPr wrap="square">
+            <a:spAutoFit/>
+          </a:bodyPr>
+          <a:lstStyle/>
+          <a:p>
+            <a:pPr algn="l"/>
+            <a:r>
+              <a:rPr sz="2400" b="1"/>
+              <a:t>Supplemental Digital Content 1. Signal decomposition</a:t>
             </a:r>
           </a:p>
         </p:txBody>
@@ -3184,7 +3588,7 @@
 </p:sld>
 </file>
 
-<file path=ppt/slides/slide2.xml><?xml version="1.0" encoding="utf-8"?>
+<file path=ppt/slides/slide6.xml><?xml version="1.0" encoding="utf-8"?>
 <p:sld xmlns:a="http://schemas.openxmlformats.org/drawingml/2006/main" xmlns:p="http://schemas.openxmlformats.org/presentationml/2006/main" xmlns:r="http://schemas.openxmlformats.org/officeDocument/2006/relationships">
   <p:cSld>
     <p:spTree>
@@ -3219,411 +3623,7 @@
             <a:pPr algn="l"/>
             <a:r>
               <a:rPr sz="2400" b="1"/>
-              <a:t>Figure 2. Concordance by scenario</a:t>
-            </a:r>
-          </a:p>
-        </p:txBody>
-      </p:sp>
-      <p:pic>
-        <p:nvPicPr>
-          <p:cNvPr id="3" name="Picture 2" descr="figure2_scenarios_concordance.png"/>
-          <p:cNvPicPr>
-            <a:picLocks noChangeAspect="1"/>
-          </p:cNvPicPr>
-          <p:nvPr/>
-        </p:nvPicPr>
-        <p:blipFill>
-          <a:blip r:embed="rId2"/>
-          <a:stretch>
-            <a:fillRect/>
-          </a:stretch>
-        </p:blipFill>
-        <p:spPr>
-          <a:xfrm>
-            <a:off x="3555847" y="960120"/>
-            <a:ext cx="5080000" cy="4572000"/>
-          </a:xfrm>
-          <a:prstGeom prst="rect">
-            <a:avLst/>
-          </a:prstGeom>
-        </p:spPr>
-      </p:pic>
-      <p:sp>
-        <p:nvSpPr>
-          <p:cNvPr id="4" name="TextBox 3"/>
-          <p:cNvSpPr txBox="1"/>
-          <p:nvPr/>
-        </p:nvSpPr>
-        <p:spPr>
-          <a:xfrm>
-            <a:off x="457200" y="5760720"/>
-            <a:ext cx="11277295" cy="914400"/>
-          </a:xfrm>
-          <a:prstGeom prst="rect">
-            <a:avLst/>
-          </a:prstGeom>
-          <a:noFill/>
-        </p:spPr>
-        <p:txBody>
-          <a:bodyPr wrap="square">
-            <a:spAutoFit/>
-          </a:bodyPr>
-          <a:lstStyle/>
-          <a:p>
-            <a:r>
-              <a:rPr sz="1300" i="1"/>
-              <a:t>Device-versus-reference concordance for the four static scenarios; each panel shows CCC, scale shift v and mean bias. S4 has near-zero bias despite a 10% gain error.</a:t>
-            </a:r>
-          </a:p>
-        </p:txBody>
-      </p:sp>
-    </p:spTree>
-  </p:cSld>
-  <p:clrMapOvr>
-    <a:masterClrMapping/>
-  </p:clrMapOvr>
-</p:sld>
-</file>
-
-<file path=ppt/slides/slide3.xml><?xml version="1.0" encoding="utf-8"?>
-<p:sld xmlns:a="http://schemas.openxmlformats.org/drawingml/2006/main" xmlns:p="http://schemas.openxmlformats.org/presentationml/2006/main" xmlns:r="http://schemas.openxmlformats.org/officeDocument/2006/relationships">
-  <p:cSld>
-    <p:spTree>
-      <p:nvGrpSpPr>
-        <p:cNvPr id="1" name=""/>
-        <p:cNvGrpSpPr/>
-        <p:nvPr/>
-      </p:nvGrpSpPr>
-      <p:grpSpPr/>
-      <p:sp>
-        <p:nvSpPr>
-          <p:cNvPr id="2" name="TextBox 1"/>
-          <p:cNvSpPr txBox="1"/>
-          <p:nvPr/>
-        </p:nvSpPr>
-        <p:spPr>
-          <a:xfrm>
-            <a:off x="457200" y="182880"/>
-            <a:ext cx="11277295" cy="640080"/>
-          </a:xfrm>
-          <a:prstGeom prst="rect">
-            <a:avLst/>
-          </a:prstGeom>
-          <a:noFill/>
-        </p:spPr>
-        <p:txBody>
-          <a:bodyPr wrap="square">
-            <a:spAutoFit/>
-          </a:bodyPr>
-          <a:lstStyle/>
-          <a:p>
-            <a:pPr algn="l"/>
-            <a:r>
-              <a:rPr sz="2400" b="1"/>
-              <a:t>Figure 3. Detection pattern</a:t>
-            </a:r>
-          </a:p>
-        </p:txBody>
-      </p:sp>
-      <p:pic>
-        <p:nvPicPr>
-          <p:cNvPr id="3" name="Picture 2" descr="figure3_detection_panel.png"/>
-          <p:cNvPicPr>
-            <a:picLocks noChangeAspect="1"/>
-          </p:cNvPicPr>
-          <p:nvPr/>
-        </p:nvPicPr>
-        <p:blipFill>
-          <a:blip r:embed="rId2"/>
-          <a:stretch>
-            <a:fillRect/>
-          </a:stretch>
-        </p:blipFill>
-        <p:spPr>
-          <a:xfrm>
-            <a:off x="2209647" y="960120"/>
-            <a:ext cx="7772400" cy="4572000"/>
-          </a:xfrm>
-          <a:prstGeom prst="rect">
-            <a:avLst/>
-          </a:prstGeom>
-        </p:spPr>
-      </p:pic>
-      <p:sp>
-        <p:nvSpPr>
-          <p:cNvPr id="4" name="TextBox 3"/>
-          <p:cNvSpPr txBox="1"/>
-          <p:nvPr/>
-        </p:nvSpPr>
-        <p:spPr>
-          <a:xfrm>
-            <a:off x="457200" y="5760720"/>
-            <a:ext cx="11277295" cy="914400"/>
-          </a:xfrm>
-          <a:prstGeom prst="rect">
-            <a:avLst/>
-          </a:prstGeom>
-          <a:noFill/>
-        </p:spPr>
-        <p:txBody>
-          <a:bodyPr wrap="square">
-            <a:spAutoFit/>
-          </a:bodyPr>
-          <a:lstStyle/>
-          <a:p>
-            <a:r>
-              <a:rPr sz="1300" i="1"/>
-              <a:t>Which reported analysis detects the error in each scenario (green = detected, grey = missed). In S4 the mean-bias summary misses the gain error that all proportional-bias–aware analyses detect.</a:t>
-            </a:r>
-          </a:p>
-        </p:txBody>
-      </p:sp>
-    </p:spTree>
-  </p:cSld>
-  <p:clrMapOvr>
-    <a:masterClrMapping/>
-  </p:clrMapOvr>
-</p:sld>
-</file>
-
-<file path=ppt/slides/slide4.xml><?xml version="1.0" encoding="utf-8"?>
-<p:sld xmlns:a="http://schemas.openxmlformats.org/drawingml/2006/main" xmlns:p="http://schemas.openxmlformats.org/presentationml/2006/main" xmlns:r="http://schemas.openxmlformats.org/officeDocument/2006/relationships">
-  <p:cSld>
-    <p:spTree>
-      <p:nvGrpSpPr>
-        <p:cNvPr id="1" name=""/>
-        <p:cNvGrpSpPr/>
-        <p:nvPr/>
-      </p:nvGrpSpPr>
-      <p:grpSpPr/>
-      <p:sp>
-        <p:nvSpPr>
-          <p:cNvPr id="2" name="TextBox 1"/>
-          <p:cNvSpPr txBox="1"/>
-          <p:nvPr/>
-        </p:nvSpPr>
-        <p:spPr>
-          <a:xfrm>
-            <a:off x="457200" y="182880"/>
-            <a:ext cx="11277295" cy="640080"/>
-          </a:xfrm>
-          <a:prstGeom prst="rect">
-            <a:avLst/>
-          </a:prstGeom>
-          <a:noFill/>
-        </p:spPr>
-        <p:txBody>
-          <a:bodyPr wrap="square">
-            <a:spAutoFit/>
-          </a:bodyPr>
-          <a:lstStyle/>
-          <a:p>
-            <a:pPr algn="l"/>
-            <a:r>
-              <a:rPr sz="2400" b="1"/>
-              <a:t>Figure 4. Bland–Altman regression</a:t>
-            </a:r>
-          </a:p>
-        </p:txBody>
-      </p:sp>
-      <p:pic>
-        <p:nvPicPr>
-          <p:cNvPr id="3" name="Picture 2" descr="figure4_ba_masked_gain.png"/>
-          <p:cNvPicPr>
-            <a:picLocks noChangeAspect="1"/>
-          </p:cNvPicPr>
-          <p:nvPr/>
-        </p:nvPicPr>
-        <p:blipFill>
-          <a:blip r:embed="rId2"/>
-          <a:stretch>
-            <a:fillRect/>
-          </a:stretch>
-        </p:blipFill>
-        <p:spPr>
-          <a:xfrm>
-            <a:off x="629325" y="960120"/>
-            <a:ext cx="10933043" cy="4572000"/>
-          </a:xfrm>
-          <a:prstGeom prst="rect">
-            <a:avLst/>
-          </a:prstGeom>
-        </p:spPr>
-      </p:pic>
-      <p:sp>
-        <p:nvSpPr>
-          <p:cNvPr id="4" name="TextBox 3"/>
-          <p:cNvSpPr txBox="1"/>
-          <p:nvPr/>
-        </p:nvSpPr>
-        <p:spPr>
-          <a:xfrm>
-            <a:off x="457200" y="5760720"/>
-            <a:ext cx="11277295" cy="914400"/>
-          </a:xfrm>
-          <a:prstGeom prst="rect">
-            <a:avLst/>
-          </a:prstGeom>
-          <a:noFill/>
-        </p:spPr>
-        <p:txBody>
-          <a:bodyPr wrap="square">
-            <a:spAutoFit/>
-          </a:bodyPr>
-          <a:lstStyle/>
-          <a:p>
-            <a:r>
-              <a:rPr sz="1300" i="1"/>
-              <a:t>Difference-versus-mean plots for S2 (flat slope) and S4 (positive slope despite near-zero mean bias), revealing the masked proportional (gain) error.</a:t>
-            </a:r>
-          </a:p>
-        </p:txBody>
-      </p:sp>
-    </p:spTree>
-  </p:cSld>
-  <p:clrMapOvr>
-    <a:masterClrMapping/>
-  </p:clrMapOvr>
-</p:sld>
-</file>
-
-<file path=ppt/slides/slide5.xml><?xml version="1.0" encoding="utf-8"?>
-<p:sld xmlns:a="http://schemas.openxmlformats.org/drawingml/2006/main" xmlns:p="http://schemas.openxmlformats.org/presentationml/2006/main" xmlns:r="http://schemas.openxmlformats.org/officeDocument/2006/relationships">
-  <p:cSld>
-    <p:spTree>
-      <p:nvGrpSpPr>
-        <p:cNvPr id="1" name=""/>
-        <p:cNvGrpSpPr/>
-        <p:nvPr/>
-      </p:nvGrpSpPr>
-      <p:grpSpPr/>
-      <p:sp>
-        <p:nvSpPr>
-          <p:cNvPr id="2" name="TextBox 1"/>
-          <p:cNvSpPr txBox="1"/>
-          <p:nvPr/>
-        </p:nvSpPr>
-        <p:spPr>
-          <a:xfrm>
-            <a:off x="457200" y="182880"/>
-            <a:ext cx="11277295" cy="640080"/>
-          </a:xfrm>
-          <a:prstGeom prst="rect">
-            <a:avLst/>
-          </a:prstGeom>
-          <a:noFill/>
-        </p:spPr>
-        <p:txBody>
-          <a:bodyPr wrap="square">
-            <a:spAutoFit/>
-          </a:bodyPr>
-          <a:lstStyle/>
-          <a:p>
-            <a:pPr algn="l"/>
-            <a:r>
-              <a:rPr sz="2400" b="1"/>
-              <a:t>Figure 5. Dynamic response</a:t>
-            </a:r>
-          </a:p>
-        </p:txBody>
-      </p:sp>
-      <p:pic>
-        <p:nvPicPr>
-          <p:cNvPr id="3" name="Picture 2" descr="figure5_dynamic_response.png"/>
-          <p:cNvPicPr>
-            <a:picLocks noChangeAspect="1"/>
-          </p:cNvPicPr>
-          <p:nvPr/>
-        </p:nvPicPr>
-        <p:blipFill>
-          <a:blip r:embed="rId2"/>
-          <a:stretch>
-            <a:fillRect/>
-          </a:stretch>
-        </p:blipFill>
-        <p:spPr>
-          <a:xfrm>
-            <a:off x="457200" y="960120"/>
-            <a:ext cx="11277295" cy="3990427"/>
-          </a:xfrm>
-          <a:prstGeom prst="rect">
-            <a:avLst/>
-          </a:prstGeom>
-        </p:spPr>
-      </p:pic>
-      <p:sp>
-        <p:nvSpPr>
-          <p:cNvPr id="4" name="TextBox 3"/>
-          <p:cNvSpPr txBox="1"/>
-          <p:nvPr/>
-        </p:nvSpPr>
-        <p:spPr>
-          <a:xfrm>
-            <a:off x="457200" y="5760720"/>
-            <a:ext cx="11277295" cy="914400"/>
-          </a:xfrm>
-          <a:prstGeom prst="rect">
-            <a:avLst/>
-          </a:prstGeom>
-          <a:noFill/>
-        </p:spPr>
-        <p:txBody>
-          <a:bodyPr wrap="square">
-            <a:spAutoFit/>
-          </a:bodyPr>
-          <a:lstStyle/>
-          <a:p>
-            <a:r>
-              <a:rPr sz="1300" i="1"/>
-              <a:t>Frequency response and waveforms for optimal, under-damped and over-damped systems, with measured-versus-true pulse pressure and the mean PP ratio.</a:t>
-            </a:r>
-          </a:p>
-        </p:txBody>
-      </p:sp>
-    </p:spTree>
-  </p:cSld>
-  <p:clrMapOvr>
-    <a:masterClrMapping/>
-  </p:clrMapOvr>
-</p:sld>
-</file>
-
-<file path=ppt/slides/slide6.xml><?xml version="1.0" encoding="utf-8"?>
-<p:sld xmlns:a="http://schemas.openxmlformats.org/drawingml/2006/main" xmlns:p="http://schemas.openxmlformats.org/presentationml/2006/main" xmlns:r="http://schemas.openxmlformats.org/officeDocument/2006/relationships">
-  <p:cSld>
-    <p:spTree>
-      <p:nvGrpSpPr>
-        <p:cNvPr id="1" name=""/>
-        <p:cNvGrpSpPr/>
-        <p:nvPr/>
-      </p:nvGrpSpPr>
-      <p:grpSpPr/>
-      <p:sp>
-        <p:nvSpPr>
-          <p:cNvPr id="2" name="TextBox 1"/>
-          <p:cNvSpPr txBox="1"/>
-          <p:nvPr/>
-        </p:nvSpPr>
-        <p:spPr>
-          <a:xfrm>
-            <a:off x="457200" y="182880"/>
-            <a:ext cx="11277295" cy="640080"/>
-          </a:xfrm>
-          <a:prstGeom prst="rect">
-            <a:avLst/>
-          </a:prstGeom>
-          <a:noFill/>
-        </p:spPr>
-        <p:txBody>
-          <a:bodyPr wrap="square">
-            <a:spAutoFit/>
-          </a:bodyPr>
-          <a:lstStyle/>
-          <a:p>
-            <a:pPr algn="l"/>
-            <a:r>
-              <a:rPr sz="2400" b="1"/>
-              <a:t>Figure 6. Range-dependence of the CCC</a:t>
+              <a:t>Supplemental Digital Content 2. Range-dependence of the CCC</a:t>
             </a:r>
           </a:p>
         </p:txBody>

</xml_diff>